<commit_message>
Agrego el hilo conductor, la presentación de la base, la descomposición del Theil y el post-hoc
</commit_message>
<xml_diff>
--- a/TP_instancia2_alquileres_CABA.pptx
+++ b/TP_instancia2_alquileres_CABA.pptx
@@ -3442,6 +3442,48 @@
         </p:nvSpPr>
         <p:spPr>
           <a:xfrm>
+            <a:off x="841248" y="402336"/>
+            <a:ext cx="10515600" cy="274320"/>
+          </a:xfrm>
+          <a:prstGeom prst="rect">
+            <a:avLst/>
+          </a:prstGeom>
+          <a:noFill/>
+        </p:spPr>
+        <p:txBody>
+          <a:bodyPr wrap="square" lIns="0" rIns="0" tIns="0" bIns="0" anchor="t">
+            <a:spAutoFit/>
+          </a:bodyPr>
+          <a:lstStyle/>
+          <a:p>
+            <a:pPr algn="l">
+              <a:lnSpc>
+                <a:spcPct val="100000"/>
+              </a:lnSpc>
+              <a:spcAft>
+                <a:spcPts val="0"/>
+              </a:spcAft>
+            </a:pPr>
+            <a:r>
+              <a:rPr sz="1050" b="1">
+                <a:solidFill>
+                  <a:srgbClr val="15505E"/>
+                </a:solidFill>
+                <a:latin typeface="Calibri"/>
+              </a:rPr>
+              <a:t>¿QUÉ ENCONTRAMOS?</a:t>
+            </a:r>
+          </a:p>
+        </p:txBody>
+      </p:sp>
+      <p:sp>
+        <p:nvSpPr>
+          <p:cNvPr id="5" name="TextBox 4"/>
+          <p:cNvSpPr txBox="1"/>
+          <p:nvPr/>
+        </p:nvSpPr>
+        <p:spPr>
+          <a:xfrm>
             <a:off x="822960" y="658368"/>
             <a:ext cx="10545775" cy="1463040"/>
           </a:xfrm>
@@ -3478,7 +3520,7 @@
       </p:sp>
       <p:sp>
         <p:nvSpPr>
-          <p:cNvPr id="5" name="TextBox 4"/>
+          <p:cNvPr id="6" name="TextBox 5"/>
           <p:cNvSpPr txBox="1"/>
           <p:nvPr/>
         </p:nvSpPr>
@@ -3520,7 +3562,7 @@
       </p:sp>
       <p:graphicFrame>
         <p:nvGraphicFramePr>
-          <p:cNvPr id="6" name="Table 5"/>
+          <p:cNvPr id="7" name="Table 6"/>
           <p:cNvGraphicFramePr>
             <a:graphicFrameLocks noGrp="1"/>
           </p:cNvGraphicFramePr>
@@ -4809,7 +4851,7 @@
       </p:graphicFrame>
       <p:sp>
         <p:nvSpPr>
-          <p:cNvPr id="7" name="TextBox 6"/>
+          <p:cNvPr id="8" name="TextBox 7"/>
           <p:cNvSpPr txBox="1"/>
           <p:nvPr/>
         </p:nvSpPr>
@@ -4851,7 +4893,7 @@
       </p:sp>
       <p:sp>
         <p:nvSpPr>
-          <p:cNvPr id="8" name="TextBox 7"/>
+          <p:cNvPr id="9" name="TextBox 8"/>
           <p:cNvSpPr txBox="1"/>
           <p:nvPr/>
         </p:nvSpPr>
@@ -4893,7 +4935,7 @@
       </p:sp>
       <p:graphicFrame>
         <p:nvGraphicFramePr>
-          <p:cNvPr id="9" name="Table 8"/>
+          <p:cNvPr id="10" name="Table 9"/>
           <p:cNvGraphicFramePr>
             <a:graphicFrameLocks noGrp="1"/>
           </p:cNvGraphicFramePr>
@@ -4901,7 +4943,7 @@
         </p:nvGraphicFramePr>
         <p:xfrm>
           <a:off x="6400800" y="2331720"/>
-          <a:ext cx="4937760" cy="1938528"/>
+          <a:ext cx="4937760" cy="1975104"/>
         </p:xfrm>
         <a:graphic>
           <a:graphicData uri="http://schemas.openxmlformats.org/drawingml/2006/table">
@@ -4910,27 +4952,28 @@
                 <a:tableStyleId>{5C22544A-7EE6-4342-B048-85BDC9FD1C3A}</a:tableStyleId>
               </a:tblPr>
               <a:tblGrid>
-                <a:gridCol w="1371600"/>
                 <a:gridCol w="1188720"/>
-                <a:gridCol w="1188720"/>
-                <a:gridCol w="1188720"/>
+                <a:gridCol w="914400"/>
+                <a:gridCol w="960120"/>
+                <a:gridCol w="914400"/>
+                <a:gridCol w="960120"/>
               </a:tblGrid>
-              <a:tr h="512064">
-                <a:tc>
-                  <a:txBody>
-                    <a:bodyPr wrap="square"/>
-                    <a:lstStyle/>
-                    <a:p>
-                      <a:pPr algn="ctr">
-                        <a:lnSpc>
-                          <a:spcPct val="102000"/>
-                        </a:lnSpc>
-                        <a:spcAft>
-                          <a:spcPts val="0"/>
-                        </a:spcAft>
-                      </a:pPr>
-                      <a:r>
-                        <a:rPr sz="1350" b="1">
+              <a:tr h="548640">
+                <a:tc>
+                  <a:txBody>
+                    <a:bodyPr wrap="square"/>
+                    <a:lstStyle/>
+                    <a:p>
+                      <a:pPr algn="ctr">
+                        <a:lnSpc>
+                          <a:spcPct val="102000"/>
+                        </a:lnSpc>
+                        <a:spcAft>
+                          <a:spcPts val="0"/>
+                        </a:spcAft>
+                      </a:pPr>
+                      <a:r>
+                        <a:rPr sz="1150" b="1">
                           <a:solidFill>
                             <a:srgbClr val="F4EFE4"/>
                           </a:solidFill>
@@ -4980,7 +5023,7 @@
                         </a:spcAft>
                       </a:pPr>
                       <a:r>
-                        <a:rPr sz="1350" b="1">
+                        <a:rPr sz="1150" b="1">
                           <a:solidFill>
                             <a:srgbClr val="F4EFE4"/>
                           </a:solidFill>
@@ -5030,7 +5073,7 @@
                         </a:spcAft>
                       </a:pPr>
                       <a:r>
-                        <a:rPr sz="1350" b="1">
+                        <a:rPr sz="1150" b="1">
                           <a:solidFill>
                             <a:srgbClr val="F4EFE4"/>
                           </a:solidFill>
@@ -5080,13 +5123,64 @@
                         </a:spcAft>
                       </a:pPr>
                       <a:r>
-                        <a:rPr sz="1350" b="1">
+                        <a:rPr sz="1150" b="1">
                           <a:solidFill>
                             <a:srgbClr val="F4EFE4"/>
                           </a:solidFill>
                           <a:latin typeface="Calibri"/>
                         </a:rPr>
                         <a:t>Theil</a:t>
+                      </a:r>
+                    </a:p>
+                  </a:txBody>
+                  <a:tcPr marL="91440" marR="91440" marT="36576" marB="36576" anchor="ctr">
+                    <a:lnB w="25400" cap="flat" cmpd="sng" algn="ctr">
+                      <a:solidFill>
+                        <a:srgbClr val="15505E"/>
+                      </a:solidFill>
+                    </a:lnB>
+                    <a:lnT w="25400" cap="flat" cmpd="sng" algn="ctr">
+                      <a:solidFill>
+                        <a:srgbClr val="15505E"/>
+                      </a:solidFill>
+                    </a:lnT>
+                    <a:lnR w="25400" cap="flat" cmpd="sng" algn="ctr">
+                      <a:solidFill>
+                        <a:srgbClr val="15505E"/>
+                      </a:solidFill>
+                    </a:lnR>
+                    <a:lnL w="25400" cap="flat" cmpd="sng" algn="ctr">
+                      <a:solidFill>
+                        <a:srgbClr val="15505E"/>
+                      </a:solidFill>
+                    </a:lnL>
+                    <a:solidFill>
+                      <a:srgbClr val="15505E"/>
+                    </a:solidFill>
+                  </a:tcPr>
+                </a:tc>
+                <a:tc>
+                  <a:txBody>
+                    <a:bodyPr wrap="square"/>
+                    <a:lstStyle/>
+                    <a:p>
+                      <a:pPr algn="ctr">
+                        <a:lnSpc>
+                          <a:spcPct val="102000"/>
+                        </a:lnSpc>
+                        <a:spcAft>
+                          <a:spcPts val="0"/>
+                        </a:spcAft>
+                      </a:pPr>
+                      <a:r>
+                        <a:rPr sz="1150" b="1">
+                          <a:solidFill>
+                            <a:srgbClr val="F4EFE4"/>
+                          </a:solidFill>
+                          <a:latin typeface="Calibri"/>
+                        </a:rPr>
+                        <a:t>% entre
+zonas</a:t>
                       </a:r>
                     </a:p>
                   </a:txBody>
@@ -5132,7 +5226,7 @@
                         </a:spcAft>
                       </a:pPr>
                       <a:r>
-                        <a:rPr sz="1400" b="0">
+                        <a:rPr sz="1250" b="0">
                           <a:solidFill>
                             <a:srgbClr val="15505E"/>
                           </a:solidFill>
@@ -5182,7 +5276,7 @@
                         </a:spcAft>
                       </a:pPr>
                       <a:r>
-                        <a:rPr sz="1400" b="0">
+                        <a:rPr sz="1250" b="0">
                           <a:solidFill>
                             <a:srgbClr val="15505E"/>
                           </a:solidFill>
@@ -5232,7 +5326,7 @@
                         </a:spcAft>
                       </a:pPr>
                       <a:r>
-                        <a:rPr sz="1400" b="0">
+                        <a:rPr sz="1250" b="0">
                           <a:solidFill>
                             <a:srgbClr val="15505E"/>
                           </a:solidFill>
@@ -5282,13 +5376,63 @@
                         </a:spcAft>
                       </a:pPr>
                       <a:r>
-                        <a:rPr sz="1400" b="0">
+                        <a:rPr sz="1250" b="0">
                           <a:solidFill>
                             <a:srgbClr val="15505E"/>
                           </a:solidFill>
                           <a:latin typeface="Calibri"/>
                         </a:rPr>
                         <a:t>5,98</a:t>
+                      </a:r>
+                    </a:p>
+                  </a:txBody>
+                  <a:tcPr marL="91440" marR="91440" marT="36576" marB="36576" anchor="ctr">
+                    <a:lnB w="25400" cap="flat" cmpd="sng" algn="ctr">
+                      <a:solidFill>
+                        <a:srgbClr val="15505E"/>
+                      </a:solidFill>
+                    </a:lnB>
+                    <a:lnT w="25400" cap="flat" cmpd="sng" algn="ctr">
+                      <a:solidFill>
+                        <a:srgbClr val="15505E"/>
+                      </a:solidFill>
+                    </a:lnT>
+                    <a:lnR w="25400" cap="flat" cmpd="sng" algn="ctr">
+                      <a:solidFill>
+                        <a:srgbClr val="15505E"/>
+                      </a:solidFill>
+                    </a:lnR>
+                    <a:lnL w="25400" cap="flat" cmpd="sng" algn="ctr">
+                      <a:solidFill>
+                        <a:srgbClr val="15505E"/>
+                      </a:solidFill>
+                    </a:lnL>
+                    <a:solidFill>
+                      <a:srgbClr val="F4EFE4"/>
+                    </a:solidFill>
+                  </a:tcPr>
+                </a:tc>
+                <a:tc>
+                  <a:txBody>
+                    <a:bodyPr wrap="square"/>
+                    <a:lstStyle/>
+                    <a:p>
+                      <a:pPr algn="ctr">
+                        <a:lnSpc>
+                          <a:spcPct val="102000"/>
+                        </a:lnSpc>
+                        <a:spcAft>
+                          <a:spcPts val="0"/>
+                        </a:spcAft>
+                      </a:pPr>
+                      <a:r>
+                        <a:rPr sz="1250" b="0">
+                          <a:solidFill>
+                            <a:srgbClr val="15505E"/>
+                          </a:solidFill>
+                          <a:latin typeface="Calibri"/>
+                        </a:rPr>
+                        <a:t>46%</a:t>
                       </a:r>
                     </a:p>
                   </a:txBody>
@@ -5334,7 +5478,7 @@
                         </a:spcAft>
                       </a:pPr>
                       <a:r>
-                        <a:rPr sz="1400" b="0">
+                        <a:rPr sz="1250" b="0">
                           <a:solidFill>
                             <a:srgbClr val="15505E"/>
                           </a:solidFill>
@@ -5384,7 +5528,7 @@
                         </a:spcAft>
                       </a:pPr>
                       <a:r>
-                        <a:rPr sz="1400" b="0">
+                        <a:rPr sz="1250" b="0">
                           <a:solidFill>
                             <a:srgbClr val="15505E"/>
                           </a:solidFill>
@@ -5434,7 +5578,7 @@
                         </a:spcAft>
                       </a:pPr>
                       <a:r>
-                        <a:rPr sz="1400" b="0">
+                        <a:rPr sz="1250" b="0">
                           <a:solidFill>
                             <a:srgbClr val="15505E"/>
                           </a:solidFill>
@@ -5484,13 +5628,63 @@
                         </a:spcAft>
                       </a:pPr>
                       <a:r>
-                        <a:rPr sz="1400" b="0">
+                        <a:rPr sz="1250" b="0">
                           <a:solidFill>
                             <a:srgbClr val="15505E"/>
                           </a:solidFill>
                           <a:latin typeface="Calibri"/>
                         </a:rPr>
                         <a:t>6,57</a:t>
+                      </a:r>
+                    </a:p>
+                  </a:txBody>
+                  <a:tcPr marL="91440" marR="91440" marT="36576" marB="36576" anchor="ctr">
+                    <a:lnB w="25400" cap="flat" cmpd="sng" algn="ctr">
+                      <a:solidFill>
+                        <a:srgbClr val="15505E"/>
+                      </a:solidFill>
+                    </a:lnB>
+                    <a:lnT w="25400" cap="flat" cmpd="sng" algn="ctr">
+                      <a:solidFill>
+                        <a:srgbClr val="15505E"/>
+                      </a:solidFill>
+                    </a:lnT>
+                    <a:lnR w="25400" cap="flat" cmpd="sng" algn="ctr">
+                      <a:solidFill>
+                        <a:srgbClr val="15505E"/>
+                      </a:solidFill>
+                    </a:lnR>
+                    <a:lnL w="25400" cap="flat" cmpd="sng" algn="ctr">
+                      <a:solidFill>
+                        <a:srgbClr val="15505E"/>
+                      </a:solidFill>
+                    </a:lnL>
+                    <a:solidFill>
+                      <a:srgbClr val="F4EFE4"/>
+                    </a:solidFill>
+                  </a:tcPr>
+                </a:tc>
+                <a:tc>
+                  <a:txBody>
+                    <a:bodyPr wrap="square"/>
+                    <a:lstStyle/>
+                    <a:p>
+                      <a:pPr algn="ctr">
+                        <a:lnSpc>
+                          <a:spcPct val="102000"/>
+                        </a:lnSpc>
+                        <a:spcAft>
+                          <a:spcPts val="0"/>
+                        </a:spcAft>
+                      </a:pPr>
+                      <a:r>
+                        <a:rPr sz="1250" b="0">
+                          <a:solidFill>
+                            <a:srgbClr val="15505E"/>
+                          </a:solidFill>
+                          <a:latin typeface="Calibri"/>
+                        </a:rPr>
+                        <a:t>24%</a:t>
                       </a:r>
                     </a:p>
                   </a:txBody>
@@ -5536,7 +5730,7 @@
                         </a:spcAft>
                       </a:pPr>
                       <a:r>
-                        <a:rPr sz="1400" b="0">
+                        <a:rPr sz="1250" b="0">
                           <a:solidFill>
                             <a:srgbClr val="15505E"/>
                           </a:solidFill>
@@ -5586,7 +5780,7 @@
                         </a:spcAft>
                       </a:pPr>
                       <a:r>
-                        <a:rPr sz="1400" b="0">
+                        <a:rPr sz="1250" b="0">
                           <a:solidFill>
                             <a:srgbClr val="15505E"/>
                           </a:solidFill>
@@ -5636,7 +5830,7 @@
                         </a:spcAft>
                       </a:pPr>
                       <a:r>
-                        <a:rPr sz="1400" b="0">
+                        <a:rPr sz="1250" b="0">
                           <a:solidFill>
                             <a:srgbClr val="15505E"/>
                           </a:solidFill>
@@ -5686,13 +5880,63 @@
                         </a:spcAft>
                       </a:pPr>
                       <a:r>
-                        <a:rPr sz="1400" b="0">
+                        <a:rPr sz="1250" b="0">
                           <a:solidFill>
                             <a:srgbClr val="15505E"/>
                           </a:solidFill>
                           <a:latin typeface="Calibri"/>
                         </a:rPr>
                         <a:t>3,65</a:t>
+                      </a:r>
+                    </a:p>
+                  </a:txBody>
+                  <a:tcPr marL="91440" marR="91440" marT="36576" marB="36576" anchor="ctr">
+                    <a:lnB w="25400" cap="flat" cmpd="sng" algn="ctr">
+                      <a:solidFill>
+                        <a:srgbClr val="15505E"/>
+                      </a:solidFill>
+                    </a:lnB>
+                    <a:lnT w="25400" cap="flat" cmpd="sng" algn="ctr">
+                      <a:solidFill>
+                        <a:srgbClr val="15505E"/>
+                      </a:solidFill>
+                    </a:lnT>
+                    <a:lnR w="25400" cap="flat" cmpd="sng" algn="ctr">
+                      <a:solidFill>
+                        <a:srgbClr val="15505E"/>
+                      </a:solidFill>
+                    </a:lnR>
+                    <a:lnL w="25400" cap="flat" cmpd="sng" algn="ctr">
+                      <a:solidFill>
+                        <a:srgbClr val="15505E"/>
+                      </a:solidFill>
+                    </a:lnL>
+                    <a:solidFill>
+                      <a:srgbClr val="F4EFE4"/>
+                    </a:solidFill>
+                  </a:tcPr>
+                </a:tc>
+                <a:tc>
+                  <a:txBody>
+                    <a:bodyPr wrap="square"/>
+                    <a:lstStyle/>
+                    <a:p>
+                      <a:pPr algn="ctr">
+                        <a:lnSpc>
+                          <a:spcPct val="102000"/>
+                        </a:lnSpc>
+                        <a:spcAft>
+                          <a:spcPts val="0"/>
+                        </a:spcAft>
+                      </a:pPr>
+                      <a:r>
+                        <a:rPr sz="1250" b="0">
+                          <a:solidFill>
+                            <a:srgbClr val="15505E"/>
+                          </a:solidFill>
+                          <a:latin typeface="Calibri"/>
+                        </a:rPr>
+                        <a:t>44%</a:t>
                       </a:r>
                     </a:p>
                   </a:txBody>
@@ -5729,14 +5973,14 @@
       </p:graphicFrame>
       <p:sp>
         <p:nvSpPr>
-          <p:cNvPr id="10" name="TextBox 9"/>
+          <p:cNvPr id="11" name="TextBox 10"/>
           <p:cNvSpPr txBox="1"/>
           <p:nvPr/>
         </p:nvSpPr>
         <p:spPr>
           <a:xfrm>
             <a:off x="6400800" y="4480560"/>
-            <a:ext cx="4937760" cy="1645920"/>
+            <a:ext cx="4937760" cy="1783080"/>
           </a:xfrm>
           <a:prstGeom prst="rect">
             <a:avLst/>
@@ -5754,17 +5998,45 @@
                 <a:spcPct val="116000"/>
               </a:lnSpc>
               <a:spcAft>
-                <a:spcPts val="1300"/>
+                <a:spcPts val="900"/>
               </a:spcAft>
             </a:pPr>
             <a:r>
-              <a:rPr sz="1600" b="0">
+              <a:rPr sz="1450" b="0">
                 <a:solidFill>
                   <a:srgbClr val="15505E"/>
                 </a:solidFill>
                 <a:latin typeface="Calibri"/>
               </a:rPr>
-              <a:t>El precio real fue más alto durante la ley (107 contra 92 y 90). Pero si sacamos 2023 cae a 98: buena parte de ese pico es el salto inflacionario, no la ley.</a:t>
+              <a:t>El precio real fue más alto durante la ley (107 contra 92 y 90). Pero si sacamos 2023 cae a 98: buena parte de ese pico es el salto inflacionario.</a:t>
+            </a:r>
+          </a:p>
+          <a:p>
+            <a:pPr>
+              <a:lnSpc>
+                <a:spcPct val="116000"/>
+              </a:lnSpc>
+              <a:spcAft>
+                <a:spcPts val="900"/>
+              </a:spcAft>
+            </a:pPr>
+            <a:r>
+              <a:rPr sz="1450" b="1">
+                <a:solidFill>
+                  <a:srgbClr val="15505E"/>
+                </a:solidFill>
+                <a:latin typeface="Calibri"/>
+              </a:rPr>
+              <a:t>Descompusimos el Theil. </a:t>
+            </a:r>
+            <a:r>
+              <a:rPr sz="1450" b="0">
+                <a:solidFill>
+                  <a:srgbClr val="15505E"/>
+                </a:solidFill>
+                <a:latin typeface="Calibri"/>
+              </a:rPr>
+              <a:t>Durante la ley solo el 24% de la desigualdad de precios era entre zonas: el resto estaba dentro de cada zona. Antes y después, casi la mitad.</a:t>
             </a:r>
           </a:p>
         </p:txBody>
@@ -5865,6 +6137,48 @@
         </p:nvSpPr>
         <p:spPr>
           <a:xfrm>
+            <a:off x="841248" y="402336"/>
+            <a:ext cx="10515600" cy="274320"/>
+          </a:xfrm>
+          <a:prstGeom prst="rect">
+            <a:avLst/>
+          </a:prstGeom>
+          <a:noFill/>
+        </p:spPr>
+        <p:txBody>
+          <a:bodyPr wrap="square" lIns="0" rIns="0" tIns="0" bIns="0" anchor="t">
+            <a:spAutoFit/>
+          </a:bodyPr>
+          <a:lstStyle/>
+          <a:p>
+            <a:pPr algn="l">
+              <a:lnSpc>
+                <a:spcPct val="100000"/>
+              </a:lnSpc>
+              <a:spcAft>
+                <a:spcPts val="0"/>
+              </a:spcAft>
+            </a:pPr>
+            <a:r>
+              <a:rPr sz="1050" b="1">
+                <a:solidFill>
+                  <a:srgbClr val="F4EFE4"/>
+                </a:solidFill>
+                <a:latin typeface="Calibri"/>
+              </a:rPr>
+              <a:t>¿QUÉ ENCONTRAMOS?</a:t>
+            </a:r>
+          </a:p>
+        </p:txBody>
+      </p:sp>
+      <p:sp>
+        <p:nvSpPr>
+          <p:cNvPr id="5" name="TextBox 4"/>
+          <p:cNvSpPr txBox="1"/>
+          <p:nvPr/>
+        </p:nvSpPr>
+        <p:spPr>
+          <a:xfrm>
             <a:off x="822960" y="658368"/>
             <a:ext cx="10545775" cy="1463040"/>
           </a:xfrm>
@@ -5901,7 +6215,7 @@
       </p:sp>
       <p:pic>
         <p:nvPicPr>
-          <p:cNvPr id="5" name="Picture 4" descr="i2_g02_indice_real.png"/>
+          <p:cNvPr id="6" name="Picture 5" descr="i2_g02_indice_real.png"/>
           <p:cNvPicPr>
             <a:picLocks noChangeAspect="1"/>
           </p:cNvPicPr>
@@ -5925,7 +6239,7 @@
       </p:pic>
       <p:pic>
         <p:nvPicPr>
-          <p:cNvPr id="6" name="Picture 5" descr="i2_g03_theil.png"/>
+          <p:cNvPr id="7" name="Picture 6" descr="i2_g03_theil.png"/>
           <p:cNvPicPr>
             <a:picLocks noChangeAspect="1"/>
           </p:cNvPicPr>
@@ -5949,7 +6263,7 @@
       </p:pic>
       <p:sp>
         <p:nvSpPr>
-          <p:cNvPr id="7" name="TextBox 6"/>
+          <p:cNvPr id="8" name="TextBox 7"/>
           <p:cNvSpPr txBox="1"/>
           <p:nvPr/>
         </p:nvSpPr>
@@ -6094,6 +6408,48 @@
         </p:nvSpPr>
         <p:spPr>
           <a:xfrm>
+            <a:off x="841248" y="402336"/>
+            <a:ext cx="10515600" cy="274320"/>
+          </a:xfrm>
+          <a:prstGeom prst="rect">
+            <a:avLst/>
+          </a:prstGeom>
+          <a:noFill/>
+        </p:spPr>
+        <p:txBody>
+          <a:bodyPr wrap="square" lIns="0" rIns="0" tIns="0" bIns="0" anchor="t">
+            <a:spAutoFit/>
+          </a:bodyPr>
+          <a:lstStyle/>
+          <a:p>
+            <a:pPr algn="l">
+              <a:lnSpc>
+                <a:spcPct val="100000"/>
+              </a:lnSpc>
+              <a:spcAft>
+                <a:spcPts val="0"/>
+              </a:spcAft>
+            </a:pPr>
+            <a:r>
+              <a:rPr sz="1050" b="1">
+                <a:solidFill>
+                  <a:srgbClr val="15505E"/>
+                </a:solidFill>
+                <a:latin typeface="Calibri"/>
+              </a:rPr>
+              <a:t>¿QUÉ MÉTODO APLICAMOS Y POR QUÉ?</a:t>
+            </a:r>
+          </a:p>
+        </p:txBody>
+      </p:sp>
+      <p:sp>
+        <p:nvSpPr>
+          <p:cNvPr id="5" name="TextBox 4"/>
+          <p:cNvSpPr txBox="1"/>
+          <p:nvPr/>
+        </p:nvSpPr>
+        <p:spPr>
+          <a:xfrm>
             <a:off x="822960" y="658368"/>
             <a:ext cx="10545775" cy="1463040"/>
           </a:xfrm>
@@ -6130,7 +6486,7 @@
       </p:sp>
       <p:sp>
         <p:nvSpPr>
-          <p:cNvPr id="5" name="TextBox 4"/>
+          <p:cNvPr id="6" name="TextBox 5"/>
           <p:cNvSpPr txBox="1"/>
           <p:nvPr/>
         </p:nvSpPr>
@@ -6229,7 +6585,7 @@
       </p:sp>
       <p:graphicFrame>
         <p:nvGraphicFramePr>
-          <p:cNvPr id="6" name="Table 5"/>
+          <p:cNvPr id="7" name="Table 6"/>
           <p:cNvGraphicFramePr>
             <a:graphicFrameLocks noGrp="1"/>
           </p:cNvGraphicFramePr>
@@ -7267,7 +7623,7 @@
       </p:graphicFrame>
       <p:sp>
         <p:nvSpPr>
-          <p:cNvPr id="7" name="TextBox 6"/>
+          <p:cNvPr id="8" name="TextBox 7"/>
           <p:cNvSpPr txBox="1"/>
           <p:nvPr/>
         </p:nvSpPr>
@@ -7403,6 +7759,48 @@
         </p:nvSpPr>
         <p:spPr>
           <a:xfrm>
+            <a:off x="841248" y="402336"/>
+            <a:ext cx="10515600" cy="274320"/>
+          </a:xfrm>
+          <a:prstGeom prst="rect">
+            <a:avLst/>
+          </a:prstGeom>
+          <a:noFill/>
+        </p:spPr>
+        <p:txBody>
+          <a:bodyPr wrap="square" lIns="0" rIns="0" tIns="0" bIns="0" anchor="t">
+            <a:spAutoFit/>
+          </a:bodyPr>
+          <a:lstStyle/>
+          <a:p>
+            <a:pPr algn="l">
+              <a:lnSpc>
+                <a:spcPct val="100000"/>
+              </a:lnSpc>
+              <a:spcAft>
+                <a:spcPts val="0"/>
+              </a:spcAft>
+            </a:pPr>
+            <a:r>
+              <a:rPr sz="1050" b="1">
+                <a:solidFill>
+                  <a:srgbClr val="F4EFE4"/>
+                </a:solidFill>
+                <a:latin typeface="Calibri"/>
+              </a:rPr>
+              <a:t>¿QUÉ MÉTODO APLICAMOS Y POR QUÉ?</a:t>
+            </a:r>
+          </a:p>
+        </p:txBody>
+      </p:sp>
+      <p:sp>
+        <p:nvSpPr>
+          <p:cNvPr id="5" name="TextBox 4"/>
+          <p:cNvSpPr txBox="1"/>
+          <p:nvPr/>
+        </p:nvSpPr>
+        <p:spPr>
+          <a:xfrm>
             <a:off x="822960" y="777240"/>
             <a:ext cx="5486400" cy="1463040"/>
           </a:xfrm>
@@ -7439,7 +7837,7 @@
       </p:sp>
       <p:sp>
         <p:nvSpPr>
-          <p:cNvPr id="5" name="TextBox 4"/>
+          <p:cNvPr id="6" name="TextBox 5"/>
           <p:cNvSpPr txBox="1"/>
           <p:nvPr/>
         </p:nvSpPr>
@@ -7500,7 +7898,7 @@
       </p:sp>
       <p:graphicFrame>
         <p:nvGraphicFramePr>
-          <p:cNvPr id="6" name="Table 5"/>
+          <p:cNvPr id="7" name="Table 6"/>
           <p:cNvGraphicFramePr>
             <a:graphicFrameLocks noGrp="1"/>
           </p:cNvGraphicFramePr>
@@ -8287,7 +8685,7 @@
       </p:graphicFrame>
       <p:pic>
         <p:nvPicPr>
-          <p:cNvPr id="7" name="Picture 6" descr="i2_g05_beta_por_zona.png"/>
+          <p:cNvPr id="8" name="Picture 7" descr="i2_g05_beta_por_zona.png"/>
           <p:cNvPicPr>
             <a:picLocks noChangeAspect="1"/>
           </p:cNvPicPr>
@@ -8301,8 +8699,8 @@
         </p:blipFill>
         <p:spPr>
           <a:xfrm>
-            <a:off x="6537960" y="1508760"/>
-            <a:ext cx="4800600" cy="2987040"/>
+            <a:off x="6629400" y="1463040"/>
+            <a:ext cx="4617720" cy="2873248"/>
           </a:xfrm>
           <a:prstGeom prst="rect">
             <a:avLst/>
@@ -8311,14 +8709,14 @@
       </p:pic>
       <p:sp>
         <p:nvSpPr>
-          <p:cNvPr id="8" name="TextBox 7"/>
+          <p:cNvPr id="9" name="TextBox 8"/>
           <p:cNvSpPr txBox="1"/>
           <p:nvPr/>
         </p:nvSpPr>
         <p:spPr>
           <a:xfrm>
-            <a:off x="6537960" y="4663440"/>
-            <a:ext cx="4800600" cy="1463040"/>
+            <a:off x="6537960" y="4498848"/>
+            <a:ext cx="4800600" cy="1737360"/>
           </a:xfrm>
           <a:prstGeom prst="rect">
             <a:avLst/>
@@ -8340,7 +8738,7 @@
               </a:spcAft>
             </a:pPr>
             <a:r>
-              <a:rPr sz="1500" b="1">
+              <a:rPr sz="1450" b="1">
                 <a:solidFill>
                   <a:srgbClr val="F4EFE4"/>
                 </a:solidFill>
@@ -8349,13 +8747,13 @@
               <a:t>El ANOVA da significativo (p = 0,042) pero no resiste las versiones robustas: </a:t>
             </a:r>
             <a:r>
-              <a:rPr sz="1500" b="0">
+              <a:rPr sz="1450" b="0">
                 <a:solidFill>
                   <a:srgbClr val="F4EFE4"/>
                 </a:solidFill>
                 <a:latin typeface="Calibri"/>
               </a:rPr>
-              <a:t>con Welch y Kruskal-Wallis sube a 0,11. Los supuestos se cumplen. El problema es que agrupar por zona pierde información: son muy heterogéneas por dentro.</a:t>
+              <a:t>con Welch y Kruskal-Wallis sube a 0,11. Los supuestos se cumplen. El post-hoc de Tukey no encuentra ningún par de zonas significativo al 5%: el más cercano es Oeste-Norte (p = 0,059). Agrupar por zona pierde información: son muy heterogéneas por dentro.</a:t>
             </a:r>
           </a:p>
         </p:txBody>
@@ -8456,6 +8854,48 @@
         </p:nvSpPr>
         <p:spPr>
           <a:xfrm>
+            <a:off x="841248" y="402336"/>
+            <a:ext cx="10515600" cy="274320"/>
+          </a:xfrm>
+          <a:prstGeom prst="rect">
+            <a:avLst/>
+          </a:prstGeom>
+          <a:noFill/>
+        </p:spPr>
+        <p:txBody>
+          <a:bodyPr wrap="square" lIns="0" rIns="0" tIns="0" bIns="0" anchor="t">
+            <a:spAutoFit/>
+          </a:bodyPr>
+          <a:lstStyle/>
+          <a:p>
+            <a:pPr algn="l">
+              <a:lnSpc>
+                <a:spcPct val="100000"/>
+              </a:lnSpc>
+              <a:spcAft>
+                <a:spcPts val="0"/>
+              </a:spcAft>
+            </a:pPr>
+            <a:r>
+              <a:rPr sz="1050" b="1">
+                <a:solidFill>
+                  <a:srgbClr val="15505E"/>
+                </a:solidFill>
+                <a:latin typeface="Calibri"/>
+              </a:rPr>
+              <a:t>¿QUÉ ENCONTRAMOS?</a:t>
+            </a:r>
+          </a:p>
+        </p:txBody>
+      </p:sp>
+      <p:sp>
+        <p:nvSpPr>
+          <p:cNvPr id="5" name="TextBox 4"/>
+          <p:cNvSpPr txBox="1"/>
+          <p:nvPr/>
+        </p:nvSpPr>
+        <p:spPr>
+          <a:xfrm>
             <a:off x="7635240" y="1417320"/>
             <a:ext cx="3703320" cy="1463040"/>
           </a:xfrm>
@@ -8492,7 +8932,7 @@
       </p:sp>
       <p:pic>
         <p:nvPicPr>
-          <p:cNvPr id="5" name="Picture 4" descr="i2_g04_beta_vs_nivel.png"/>
+          <p:cNvPr id="6" name="Picture 5" descr="i2_g04_beta_vs_nivel.png"/>
           <p:cNvPicPr>
             <a:picLocks noChangeAspect="1"/>
           </p:cNvPicPr>
@@ -8516,7 +8956,7 @@
       </p:pic>
       <p:sp>
         <p:nvSpPr>
-          <p:cNvPr id="6" name="TextBox 5"/>
+          <p:cNvPr id="7" name="TextBox 6"/>
           <p:cNvSpPr txBox="1"/>
           <p:nvPr/>
         </p:nvSpPr>
@@ -8577,7 +9017,7 @@
       </p:sp>
       <p:graphicFrame>
         <p:nvGraphicFramePr>
-          <p:cNvPr id="7" name="Table 6"/>
+          <p:cNvPr id="8" name="Table 7"/>
           <p:cNvGraphicFramePr>
             <a:graphicFrameLocks noGrp="1"/>
           </p:cNvGraphicFramePr>
@@ -9458,6 +9898,48 @@
         </p:nvSpPr>
         <p:spPr>
           <a:xfrm>
+            <a:off x="841248" y="402336"/>
+            <a:ext cx="10515600" cy="274320"/>
+          </a:xfrm>
+          <a:prstGeom prst="rect">
+            <a:avLst/>
+          </a:prstGeom>
+          <a:noFill/>
+        </p:spPr>
+        <p:txBody>
+          <a:bodyPr wrap="square" lIns="0" rIns="0" tIns="0" bIns="0" anchor="t">
+            <a:spAutoFit/>
+          </a:bodyPr>
+          <a:lstStyle/>
+          <a:p>
+            <a:pPr algn="l">
+              <a:lnSpc>
+                <a:spcPct val="100000"/>
+              </a:lnSpc>
+              <a:spcAft>
+                <a:spcPts val="0"/>
+              </a:spcAft>
+            </a:pPr>
+            <a:r>
+              <a:rPr sz="1050" b="1">
+                <a:solidFill>
+                  <a:srgbClr val="F4EFE4"/>
+                </a:solidFill>
+                <a:latin typeface="Calibri"/>
+              </a:rPr>
+              <a:t>¿QUÉ ENCONTRAMOS?</a:t>
+            </a:r>
+          </a:p>
+        </p:txBody>
+      </p:sp>
+      <p:sp>
+        <p:nvSpPr>
+          <p:cNvPr id="5" name="TextBox 4"/>
+          <p:cNvSpPr txBox="1"/>
+          <p:nvPr/>
+        </p:nvSpPr>
+        <p:spPr>
+          <a:xfrm>
             <a:off x="822960" y="658368"/>
             <a:ext cx="10545775" cy="1463040"/>
           </a:xfrm>
@@ -9494,7 +9976,7 @@
       </p:sp>
       <p:pic>
         <p:nvPicPr>
-          <p:cNvPr id="5" name="Picture 4" descr="i2_g06_asimetria.png"/>
+          <p:cNvPr id="6" name="Picture 5" descr="i2_g06_asimetria.png"/>
           <p:cNvPicPr>
             <a:picLocks noChangeAspect="1"/>
           </p:cNvPicPr>
@@ -9518,7 +10000,7 @@
       </p:pic>
       <p:sp>
         <p:nvSpPr>
-          <p:cNvPr id="6" name="TextBox 5"/>
+          <p:cNvPr id="7" name="TextBox 6"/>
           <p:cNvSpPr txBox="1"/>
           <p:nvPr/>
         </p:nvSpPr>
@@ -9711,6 +10193,48 @@
         </p:nvSpPr>
         <p:spPr>
           <a:xfrm>
+            <a:off x="841248" y="402336"/>
+            <a:ext cx="10515600" cy="274320"/>
+          </a:xfrm>
+          <a:prstGeom prst="rect">
+            <a:avLst/>
+          </a:prstGeom>
+          <a:noFill/>
+        </p:spPr>
+        <p:txBody>
+          <a:bodyPr wrap="square" lIns="0" rIns="0" tIns="0" bIns="0" anchor="t">
+            <a:spAutoFit/>
+          </a:bodyPr>
+          <a:lstStyle/>
+          <a:p>
+            <a:pPr algn="l">
+              <a:lnSpc>
+                <a:spcPct val="100000"/>
+              </a:lnSpc>
+              <a:spcAft>
+                <a:spcPts val="0"/>
+              </a:spcAft>
+            </a:pPr>
+            <a:r>
+              <a:rPr sz="1050" b="1">
+                <a:solidFill>
+                  <a:srgbClr val="15505E"/>
+                </a:solidFill>
+                <a:latin typeface="Calibri"/>
+              </a:rPr>
+              <a:t>¿QUÉ SIGNIFICA PARA NUESTRA HIPÓTESIS?</a:t>
+            </a:r>
+          </a:p>
+        </p:txBody>
+      </p:sp>
+      <p:sp>
+        <p:nvSpPr>
+          <p:cNvPr id="5" name="TextBox 4"/>
+          <p:cNvSpPr txBox="1"/>
+          <p:nvPr/>
+        </p:nvSpPr>
+        <p:spPr>
+          <a:xfrm>
             <a:off x="822960" y="777240"/>
             <a:ext cx="5760720" cy="1463040"/>
           </a:xfrm>
@@ -9747,7 +10271,7 @@
       </p:sp>
       <p:sp>
         <p:nvSpPr>
-          <p:cNvPr id="5" name="TextBox 4"/>
+          <p:cNvPr id="6" name="TextBox 5"/>
           <p:cNvSpPr txBox="1"/>
           <p:nvPr/>
         </p:nvSpPr>
@@ -9884,7 +10408,7 @@
       </p:sp>
       <p:sp>
         <p:nvSpPr>
-          <p:cNvPr id="6" name="TextBox 5"/>
+          <p:cNvPr id="7" name="TextBox 6"/>
           <p:cNvSpPr txBox="1"/>
           <p:nvPr/>
         </p:nvSpPr>
@@ -9926,7 +10450,7 @@
       </p:sp>
       <p:sp>
         <p:nvSpPr>
-          <p:cNvPr id="7" name="TextBox 6"/>
+          <p:cNvPr id="8" name="TextBox 7"/>
           <p:cNvSpPr txBox="1"/>
           <p:nvPr/>
         </p:nvSpPr>
@@ -10100,6 +10624,48 @@
         </p:nvSpPr>
         <p:spPr>
           <a:xfrm>
+            <a:off x="841248" y="402336"/>
+            <a:ext cx="10515600" cy="274320"/>
+          </a:xfrm>
+          <a:prstGeom prst="rect">
+            <a:avLst/>
+          </a:prstGeom>
+          <a:noFill/>
+        </p:spPr>
+        <p:txBody>
+          <a:bodyPr wrap="square" lIns="0" rIns="0" tIns="0" bIns="0" anchor="t">
+            <a:spAutoFit/>
+          </a:bodyPr>
+          <a:lstStyle/>
+          <a:p>
+            <a:pPr algn="l">
+              <a:lnSpc>
+                <a:spcPct val="100000"/>
+              </a:lnSpc>
+              <a:spcAft>
+                <a:spcPts val="0"/>
+              </a:spcAft>
+            </a:pPr>
+            <a:r>
+              <a:rPr sz="1050" b="1">
+                <a:solidFill>
+                  <a:srgbClr val="15505E"/>
+                </a:solidFill>
+                <a:latin typeface="Calibri"/>
+              </a:rPr>
+              <a:t>¿DE DÓNDE VENIMOS?</a:t>
+            </a:r>
+          </a:p>
+        </p:txBody>
+      </p:sp>
+      <p:sp>
+        <p:nvSpPr>
+          <p:cNvPr id="5" name="TextBox 4"/>
+          <p:cNvSpPr txBox="1"/>
+          <p:nvPr/>
+        </p:nvSpPr>
+        <p:spPr>
+          <a:xfrm>
             <a:off x="822960" y="658368"/>
             <a:ext cx="10545775" cy="1463040"/>
           </a:xfrm>
@@ -10136,7 +10702,7 @@
       </p:sp>
       <p:sp>
         <p:nvSpPr>
-          <p:cNvPr id="5" name="TextBox 4"/>
+          <p:cNvPr id="6" name="TextBox 5"/>
           <p:cNvSpPr txBox="1"/>
           <p:nvPr/>
         </p:nvSpPr>
@@ -10187,7 +10753,7 @@
       </p:sp>
       <p:graphicFrame>
         <p:nvGraphicFramePr>
-          <p:cNvPr id="6" name="Table 5"/>
+          <p:cNvPr id="7" name="Table 6"/>
           <p:cNvGraphicFramePr>
             <a:graphicFrameLocks noGrp="1"/>
           </p:cNvGraphicFramePr>
@@ -16657,7 +17223,7 @@
       </p:graphicFrame>
       <p:sp>
         <p:nvSpPr>
-          <p:cNvPr id="7" name="TextBox 6"/>
+          <p:cNvPr id="8" name="TextBox 7"/>
           <p:cNvSpPr txBox="1"/>
           <p:nvPr/>
         </p:nvSpPr>
@@ -16793,6 +17359,48 @@
         </p:nvSpPr>
         <p:spPr>
           <a:xfrm>
+            <a:off x="841248" y="402336"/>
+            <a:ext cx="10515600" cy="274320"/>
+          </a:xfrm>
+          <a:prstGeom prst="rect">
+            <a:avLst/>
+          </a:prstGeom>
+          <a:noFill/>
+        </p:spPr>
+        <p:txBody>
+          <a:bodyPr wrap="square" lIns="0" rIns="0" tIns="0" bIns="0" anchor="t">
+            <a:spAutoFit/>
+          </a:bodyPr>
+          <a:lstStyle/>
+          <a:p>
+            <a:pPr algn="l">
+              <a:lnSpc>
+                <a:spcPct val="100000"/>
+              </a:lnSpc>
+              <a:spcAft>
+                <a:spcPts val="0"/>
+              </a:spcAft>
+            </a:pPr>
+            <a:r>
+              <a:rPr sz="1050" b="1">
+                <a:solidFill>
+                  <a:srgbClr val="F4EFE4"/>
+                </a:solidFill>
+                <a:latin typeface="Calibri"/>
+              </a:rPr>
+              <a:t>¿DE DÓNDE VENIMOS?</a:t>
+            </a:r>
+          </a:p>
+        </p:txBody>
+      </p:sp>
+      <p:sp>
+        <p:nvSpPr>
+          <p:cNvPr id="5" name="TextBox 4"/>
+          <p:cNvSpPr txBox="1"/>
+          <p:nvPr/>
+        </p:nvSpPr>
+        <p:spPr>
+          <a:xfrm>
             <a:off x="822960" y="658368"/>
             <a:ext cx="10545775" cy="1463040"/>
           </a:xfrm>
@@ -16829,7 +17437,7 @@
       </p:sp>
       <p:sp>
         <p:nvSpPr>
-          <p:cNvPr id="5" name="TextBox 4"/>
+          <p:cNvPr id="6" name="TextBox 5"/>
           <p:cNvSpPr txBox="1"/>
           <p:nvPr/>
         </p:nvSpPr>
@@ -16880,7 +17488,7 @@
       </p:sp>
       <p:graphicFrame>
         <p:nvGraphicFramePr>
-          <p:cNvPr id="6" name="Table 5"/>
+          <p:cNvPr id="7" name="Table 6"/>
           <p:cNvGraphicFramePr>
             <a:graphicFrameLocks noGrp="1"/>
           </p:cNvGraphicFramePr>
@@ -17930,7 +18538,7 @@
       </p:graphicFrame>
       <p:sp>
         <p:nvSpPr>
-          <p:cNvPr id="7" name="TextBox 6"/>
+          <p:cNvPr id="8" name="TextBox 7"/>
           <p:cNvSpPr txBox="1"/>
           <p:nvPr/>
         </p:nvSpPr>
@@ -18075,6 +18683,48 @@
         </p:nvSpPr>
         <p:spPr>
           <a:xfrm>
+            <a:off x="841248" y="402336"/>
+            <a:ext cx="10515600" cy="274320"/>
+          </a:xfrm>
+          <a:prstGeom prst="rect">
+            <a:avLst/>
+          </a:prstGeom>
+          <a:noFill/>
+        </p:spPr>
+        <p:txBody>
+          <a:bodyPr wrap="square" lIns="0" rIns="0" tIns="0" bIns="0" anchor="t">
+            <a:spAutoFit/>
+          </a:bodyPr>
+          <a:lstStyle/>
+          <a:p>
+            <a:pPr algn="l">
+              <a:lnSpc>
+                <a:spcPct val="100000"/>
+              </a:lnSpc>
+              <a:spcAft>
+                <a:spcPts val="0"/>
+              </a:spcAft>
+            </a:pPr>
+            <a:r>
+              <a:rPr sz="1050" b="1">
+                <a:solidFill>
+                  <a:srgbClr val="15505E"/>
+                </a:solidFill>
+                <a:latin typeface="Calibri"/>
+              </a:rPr>
+              <a:t>¿DE DÓNDE VENIMOS?</a:t>
+            </a:r>
+          </a:p>
+        </p:txBody>
+      </p:sp>
+      <p:sp>
+        <p:nvSpPr>
+          <p:cNvPr id="5" name="TextBox 4"/>
+          <p:cNvSpPr txBox="1"/>
+          <p:nvPr/>
+        </p:nvSpPr>
+        <p:spPr>
+          <a:xfrm>
             <a:off x="822960" y="658368"/>
             <a:ext cx="10545775" cy="1463040"/>
           </a:xfrm>
@@ -18111,14 +18761,14 @@
       </p:sp>
       <p:sp>
         <p:nvSpPr>
-          <p:cNvPr id="5" name="TextBox 4"/>
+          <p:cNvPr id="6" name="TextBox 5"/>
           <p:cNvSpPr txBox="1"/>
           <p:nvPr/>
         </p:nvSpPr>
         <p:spPr>
           <a:xfrm>
-            <a:off x="822960" y="1965960"/>
-            <a:ext cx="10515600" cy="731520"/>
+            <a:off x="822960" y="1554480"/>
+            <a:ext cx="10515600" cy="1371600"/>
           </a:xfrm>
           <a:prstGeom prst="rect">
             <a:avLst/>
@@ -18136,31 +18786,68 @@
                 <a:spcPct val="116000"/>
               </a:lnSpc>
               <a:spcAft>
-                <a:spcPts val="1300"/>
+                <a:spcPts val="800"/>
               </a:spcAft>
             </a:pPr>
             <a:r>
-              <a:rPr sz="1700" b="0">
+              <a:rPr sz="1450" b="1">
                 <a:solidFill>
                   <a:srgbClr val="15505E"/>
                 </a:solidFill>
                 <a:latin typeface="Calibri"/>
               </a:rPr>
-              <a:t>Decir que la jerarquía de precios entre comunas es estable describe, pero no explica nada. Buscamos dos regularidades que sí pidan una explicación.</a:t>
+              <a:t>La base. </a:t>
+            </a:r>
+            <a:r>
+              <a:rPr sz="1450" b="0">
+                <a:solidFill>
+                  <a:srgbClr val="15505E"/>
+                </a:solidFill>
+                <a:latin typeface="Calibri"/>
+              </a:rPr>
+              <a:t>Precio promedio de publicación de departamentos en alquiler por comuna, del Instituto de Estadística y Censos de la Ciudad, con datos de Argenprop. Cada observación es una comuna, para un tipo de departamento, en un trimestre: 1.530 en total, entre 2018-T1 y 2026-T2.</a:t>
+            </a:r>
+          </a:p>
+          <a:p>
+            <a:pPr>
+              <a:lnSpc>
+                <a:spcPct val="116000"/>
+              </a:lnSpc>
+              <a:spcAft>
+                <a:spcPts val="800"/>
+              </a:spcAft>
+            </a:pPr>
+            <a:r>
+              <a:rPr sz="1450" b="1">
+                <a:solidFill>
+                  <a:srgbClr val="15505E"/>
+                </a:solidFill>
+                <a:latin typeface="Calibri"/>
+              </a:rPr>
+              <a:t>Antes teníamos una hipótesis descriptiva. </a:t>
+            </a:r>
+            <a:r>
+              <a:rPr sz="1450" b="0">
+                <a:solidFill>
+                  <a:srgbClr val="15505E"/>
+                </a:solidFill>
+                <a:latin typeface="Calibri"/>
+              </a:rPr>
+              <a:t>Decíamos que la jerarquía de precios entre comunas es estable. Describe, pero no explica nada: le pasa a casi cualquier ciudad.</a:t>
             </a:r>
           </a:p>
         </p:txBody>
       </p:sp>
       <p:sp>
         <p:nvSpPr>
-          <p:cNvPr id="6" name="TextBox 5"/>
+          <p:cNvPr id="7" name="TextBox 6"/>
           <p:cNvSpPr txBox="1"/>
           <p:nvPr/>
         </p:nvSpPr>
         <p:spPr>
           <a:xfrm>
-            <a:off x="822960" y="3017520"/>
-            <a:ext cx="5029200" cy="2834640"/>
+            <a:off x="822960" y="3063240"/>
+            <a:ext cx="5029200" cy="2697480"/>
           </a:xfrm>
           <a:prstGeom prst="rect">
             <a:avLst/>
@@ -18214,14 +18901,14 @@
       </p:sp>
       <p:sp>
         <p:nvSpPr>
-          <p:cNvPr id="7" name="TextBox 6"/>
+          <p:cNvPr id="8" name="TextBox 7"/>
           <p:cNvSpPr txBox="1"/>
           <p:nvPr/>
         </p:nvSpPr>
         <p:spPr>
           <a:xfrm>
-            <a:off x="6355080" y="3017520"/>
-            <a:ext cx="4983480" cy="2834640"/>
+            <a:off x="6355080" y="3063240"/>
+            <a:ext cx="4983480" cy="2697480"/>
           </a:xfrm>
           <a:prstGeom prst="rect">
             <a:avLst/>
@@ -18269,6 +18956,57 @@
                 <a:latin typeface="Calibri"/>
               </a:rPr>
               <a:t>En finanzas la beta mide cuánto se mueve un activo cuando se mueve el mercado. Pensamos que las comunas caras funcionan como un activo de beta alta: suben más en los auges y caen más en las bajas.</a:t>
+            </a:r>
+          </a:p>
+        </p:txBody>
+      </p:sp>
+      <p:sp>
+        <p:nvSpPr>
+          <p:cNvPr id="9" name="TextBox 8"/>
+          <p:cNvSpPr txBox="1"/>
+          <p:nvPr/>
+        </p:nvSpPr>
+        <p:spPr>
+          <a:xfrm>
+            <a:off x="822960" y="5897880"/>
+            <a:ext cx="10515600" cy="457200"/>
+          </a:xfrm>
+          <a:prstGeom prst="rect">
+            <a:avLst/>
+          </a:prstGeom>
+          <a:noFill/>
+        </p:spPr>
+        <p:txBody>
+          <a:bodyPr wrap="square" lIns="0" rIns="0" tIns="0" bIns="0" anchor="t">
+            <a:spAutoFit/>
+          </a:bodyPr>
+          <a:lstStyle/>
+          <a:p>
+            <a:pPr algn="l">
+              <a:lnSpc>
+                <a:spcPct val="116000"/>
+              </a:lnSpc>
+              <a:spcAft>
+                <a:spcPts val="1300"/>
+              </a:spcAft>
+            </a:pPr>
+            <a:r>
+              <a:rPr sz="1450" b="1">
+                <a:solidFill>
+                  <a:srgbClr val="15505E"/>
+                </a:solidFill>
+                <a:latin typeface="Calibri"/>
+              </a:rPr>
+              <a:t>El trabajo es exploratorio: </a:t>
+            </a:r>
+            <a:r>
+              <a:rPr sz="1450" b="0">
+                <a:solidFill>
+                  <a:srgbClr val="15505E"/>
+                </a:solidFill>
+                <a:latin typeface="Calibri"/>
+              </a:rPr>
+              <a:t>los métodos que siguen muestran asociaciones, no relaciones de causa y efecto.</a:t>
             </a:r>
           </a:p>
         </p:txBody>
@@ -18369,6 +19107,48 @@
         </p:nvSpPr>
         <p:spPr>
           <a:xfrm>
+            <a:off x="841248" y="402336"/>
+            <a:ext cx="10515600" cy="274320"/>
+          </a:xfrm>
+          <a:prstGeom prst="rect">
+            <a:avLst/>
+          </a:prstGeom>
+          <a:noFill/>
+        </p:spPr>
+        <p:txBody>
+          <a:bodyPr wrap="square" lIns="0" rIns="0" tIns="0" bIns="0" anchor="t">
+            <a:spAutoFit/>
+          </a:bodyPr>
+          <a:lstStyle/>
+          <a:p>
+            <a:pPr algn="l">
+              <a:lnSpc>
+                <a:spcPct val="100000"/>
+              </a:lnSpc>
+              <a:spcAft>
+                <a:spcPts val="0"/>
+              </a:spcAft>
+            </a:pPr>
+            <a:r>
+              <a:rPr sz="1050" b="1">
+                <a:solidFill>
+                  <a:srgbClr val="F4EFE4"/>
+                </a:solidFill>
+                <a:latin typeface="Calibri"/>
+              </a:rPr>
+              <a:t>¿QUÉ HICIMOS CON LOS FALTANTES Y LOS OUTLIERS?</a:t>
+            </a:r>
+          </a:p>
+        </p:txBody>
+      </p:sp>
+      <p:sp>
+        <p:nvSpPr>
+          <p:cNvPr id="5" name="TextBox 4"/>
+          <p:cNvSpPr txBox="1"/>
+          <p:nvPr/>
+        </p:nvSpPr>
+        <p:spPr>
+          <a:xfrm>
             <a:off x="822960" y="777240"/>
             <a:ext cx="4389120" cy="1463040"/>
           </a:xfrm>
@@ -18405,7 +19185,7 @@
       </p:sp>
       <p:sp>
         <p:nvSpPr>
-          <p:cNvPr id="5" name="TextBox 4"/>
+          <p:cNvPr id="6" name="TextBox 5"/>
           <p:cNvSpPr txBox="1"/>
           <p:nvPr/>
         </p:nvSpPr>
@@ -18542,7 +19322,7 @@
       </p:sp>
       <p:graphicFrame>
         <p:nvGraphicFramePr>
-          <p:cNvPr id="6" name="Table 5"/>
+          <p:cNvPr id="7" name="Table 6"/>
           <p:cNvGraphicFramePr>
             <a:graphicFrameLocks noGrp="1"/>
           </p:cNvGraphicFramePr>
@@ -19580,6 +20360,48 @@
         </p:nvSpPr>
         <p:spPr>
           <a:xfrm>
+            <a:off x="841248" y="402336"/>
+            <a:ext cx="10515600" cy="274320"/>
+          </a:xfrm>
+          <a:prstGeom prst="rect">
+            <a:avLst/>
+          </a:prstGeom>
+          <a:noFill/>
+        </p:spPr>
+        <p:txBody>
+          <a:bodyPr wrap="square" lIns="0" rIns="0" tIns="0" bIns="0" anchor="t">
+            <a:spAutoFit/>
+          </a:bodyPr>
+          <a:lstStyle/>
+          <a:p>
+            <a:pPr algn="l">
+              <a:lnSpc>
+                <a:spcPct val="100000"/>
+              </a:lnSpc>
+              <a:spcAft>
+                <a:spcPts val="0"/>
+              </a:spcAft>
+            </a:pPr>
+            <a:r>
+              <a:rPr sz="1050" b="1">
+                <a:solidFill>
+                  <a:srgbClr val="15505E"/>
+                </a:solidFill>
+                <a:latin typeface="Calibri"/>
+              </a:rPr>
+              <a:t>¿QUÉ HICIMOS CON LOS FALTANTES Y LOS OUTLIERS?</a:t>
+            </a:r>
+          </a:p>
+        </p:txBody>
+      </p:sp>
+      <p:sp>
+        <p:nvSpPr>
+          <p:cNvPr id="5" name="TextBox 4"/>
+          <p:cNvSpPr txBox="1"/>
+          <p:nvPr/>
+        </p:nvSpPr>
+        <p:spPr>
+          <a:xfrm>
             <a:off x="822960" y="658368"/>
             <a:ext cx="10545775" cy="1463040"/>
           </a:xfrm>
@@ -19616,7 +20438,7 @@
       </p:sp>
       <p:sp>
         <p:nvSpPr>
-          <p:cNvPr id="5" name="TextBox 4"/>
+          <p:cNvPr id="6" name="TextBox 5"/>
           <p:cNvSpPr txBox="1"/>
           <p:nvPr/>
         </p:nvSpPr>
@@ -19658,7 +20480,7 @@
       </p:sp>
       <p:graphicFrame>
         <p:nvGraphicFramePr>
-          <p:cNvPr id="6" name="Table 5"/>
+          <p:cNvPr id="7" name="Table 6"/>
           <p:cNvGraphicFramePr>
             <a:graphicFrameLocks noGrp="1"/>
           </p:cNvGraphicFramePr>
@@ -19888,7 +20710,7 @@
       </p:graphicFrame>
       <p:sp>
         <p:nvSpPr>
-          <p:cNvPr id="7" name="TextBox 6"/>
+          <p:cNvPr id="8" name="TextBox 7"/>
           <p:cNvSpPr txBox="1"/>
           <p:nvPr/>
         </p:nvSpPr>
@@ -20033,6 +20855,48 @@
         </p:nvSpPr>
         <p:spPr>
           <a:xfrm>
+            <a:off x="841248" y="402336"/>
+            <a:ext cx="10515600" cy="274320"/>
+          </a:xfrm>
+          <a:prstGeom prst="rect">
+            <a:avLst/>
+          </a:prstGeom>
+          <a:noFill/>
+        </p:spPr>
+        <p:txBody>
+          <a:bodyPr wrap="square" lIns="0" rIns="0" tIns="0" bIns="0" anchor="t">
+            <a:spAutoFit/>
+          </a:bodyPr>
+          <a:lstStyle/>
+          <a:p>
+            <a:pPr algn="l">
+              <a:lnSpc>
+                <a:spcPct val="100000"/>
+              </a:lnSpc>
+              <a:spcAft>
+                <a:spcPts val="0"/>
+              </a:spcAft>
+            </a:pPr>
+            <a:r>
+              <a:rPr sz="1050" b="1">
+                <a:solidFill>
+                  <a:srgbClr val="F4EFE4"/>
+                </a:solidFill>
+                <a:latin typeface="Calibri"/>
+              </a:rPr>
+              <a:t>¿QUÉ HICIMOS CON LOS FALTANTES Y LOS OUTLIERS?</a:t>
+            </a:r>
+          </a:p>
+        </p:txBody>
+      </p:sp>
+      <p:sp>
+        <p:nvSpPr>
+          <p:cNvPr id="5" name="TextBox 4"/>
+          <p:cNvSpPr txBox="1"/>
+          <p:nvPr/>
+        </p:nvSpPr>
+        <p:spPr>
+          <a:xfrm>
             <a:off x="822960" y="658368"/>
             <a:ext cx="10545775" cy="1463040"/>
           </a:xfrm>
@@ -20069,7 +20933,7 @@
       </p:sp>
       <p:sp>
         <p:nvSpPr>
-          <p:cNvPr id="5" name="TextBox 4"/>
+          <p:cNvPr id="6" name="TextBox 5"/>
           <p:cNvSpPr txBox="1"/>
           <p:nvPr/>
         </p:nvSpPr>
@@ -20168,7 +21032,7 @@
       </p:sp>
       <p:graphicFrame>
         <p:nvGraphicFramePr>
-          <p:cNvPr id="6" name="Table 5"/>
+          <p:cNvPr id="7" name="Table 6"/>
           <p:cNvGraphicFramePr>
             <a:graphicFrameLocks noGrp="1"/>
           </p:cNvGraphicFramePr>
@@ -20651,7 +21515,7 @@
       </p:graphicFrame>
       <p:sp>
         <p:nvSpPr>
-          <p:cNvPr id="7" name="TextBox 6"/>
+          <p:cNvPr id="8" name="TextBox 7"/>
           <p:cNvSpPr txBox="1"/>
           <p:nvPr/>
         </p:nvSpPr>
@@ -20796,6 +21660,48 @@
         </p:nvSpPr>
         <p:spPr>
           <a:xfrm>
+            <a:off x="841248" y="402336"/>
+            <a:ext cx="10515600" cy="274320"/>
+          </a:xfrm>
+          <a:prstGeom prst="rect">
+            <a:avLst/>
+          </a:prstGeom>
+          <a:noFill/>
+        </p:spPr>
+        <p:txBody>
+          <a:bodyPr wrap="square" lIns="0" rIns="0" tIns="0" bIns="0" anchor="t">
+            <a:spAutoFit/>
+          </a:bodyPr>
+          <a:lstStyle/>
+          <a:p>
+            <a:pPr algn="l">
+              <a:lnSpc>
+                <a:spcPct val="100000"/>
+              </a:lnSpc>
+              <a:spcAft>
+                <a:spcPts val="0"/>
+              </a:spcAft>
+            </a:pPr>
+            <a:r>
+              <a:rPr sz="1050" b="1">
+                <a:solidFill>
+                  <a:srgbClr val="15505E"/>
+                </a:solidFill>
+                <a:latin typeface="Calibri"/>
+              </a:rPr>
+              <a:t>¿QUÉ MÉTODO APLICAMOS Y POR QUÉ?</a:t>
+            </a:r>
+          </a:p>
+        </p:txBody>
+      </p:sp>
+      <p:sp>
+        <p:nvSpPr>
+          <p:cNvPr id="5" name="TextBox 4"/>
+          <p:cNvSpPr txBox="1"/>
+          <p:nvPr/>
+        </p:nvSpPr>
+        <p:spPr>
+          <a:xfrm>
             <a:off x="822960" y="658368"/>
             <a:ext cx="10545775" cy="1463040"/>
           </a:xfrm>
@@ -20832,7 +21738,7 @@
       </p:sp>
       <p:pic>
         <p:nvPicPr>
-          <p:cNvPr id="5" name="Picture 4" descr="i2_g01_faltantes_trimestre.png"/>
+          <p:cNvPr id="6" name="Picture 5" descr="i2_g01_faltantes_trimestre.png"/>
           <p:cNvPicPr>
             <a:picLocks noChangeAspect="1"/>
           </p:cNvPicPr>
@@ -20856,7 +21762,7 @@
       </p:pic>
       <p:sp>
         <p:nvSpPr>
-          <p:cNvPr id="6" name="TextBox 5"/>
+          <p:cNvPr id="7" name="TextBox 6"/>
           <p:cNvSpPr txBox="1"/>
           <p:nvPr/>
         </p:nvSpPr>
@@ -21049,6 +21955,48 @@
         </p:nvSpPr>
         <p:spPr>
           <a:xfrm>
+            <a:off x="841248" y="402336"/>
+            <a:ext cx="10515600" cy="274320"/>
+          </a:xfrm>
+          <a:prstGeom prst="rect">
+            <a:avLst/>
+          </a:prstGeom>
+          <a:noFill/>
+        </p:spPr>
+        <p:txBody>
+          <a:bodyPr wrap="square" lIns="0" rIns="0" tIns="0" bIns="0" anchor="t">
+            <a:spAutoFit/>
+          </a:bodyPr>
+          <a:lstStyle/>
+          <a:p>
+            <a:pPr algn="l">
+              <a:lnSpc>
+                <a:spcPct val="100000"/>
+              </a:lnSpc>
+              <a:spcAft>
+                <a:spcPts val="0"/>
+              </a:spcAft>
+            </a:pPr>
+            <a:r>
+              <a:rPr sz="1050" b="1">
+                <a:solidFill>
+                  <a:srgbClr val="F4EFE4"/>
+                </a:solidFill>
+                <a:latin typeface="Calibri"/>
+              </a:rPr>
+              <a:t>¿QUÉ MÉTODO APLICAMOS Y POR QUÉ?</a:t>
+            </a:r>
+          </a:p>
+        </p:txBody>
+      </p:sp>
+      <p:sp>
+        <p:nvSpPr>
+          <p:cNvPr id="5" name="TextBox 4"/>
+          <p:cNvSpPr txBox="1"/>
+          <p:nvPr/>
+        </p:nvSpPr>
+        <p:spPr>
+          <a:xfrm>
             <a:off x="822960" y="777240"/>
             <a:ext cx="4937760" cy="1463040"/>
           </a:xfrm>
@@ -21085,7 +22033,7 @@
       </p:sp>
       <p:sp>
         <p:nvSpPr>
-          <p:cNvPr id="5" name="TextBox 4"/>
+          <p:cNvPr id="6" name="TextBox 5"/>
           <p:cNvSpPr txBox="1"/>
           <p:nvPr/>
         </p:nvSpPr>
@@ -21184,7 +22132,7 @@
       </p:sp>
       <p:graphicFrame>
         <p:nvGraphicFramePr>
-          <p:cNvPr id="6" name="Table 5"/>
+          <p:cNvPr id="7" name="Table 6"/>
           <p:cNvGraphicFramePr>
             <a:graphicFrameLocks noGrp="1"/>
           </p:cNvGraphicFramePr>
@@ -22221,7 +23169,7 @@
       </p:graphicFrame>
       <p:sp>
         <p:nvSpPr>
-          <p:cNvPr id="7" name="TextBox 6"/>
+          <p:cNvPr id="8" name="TextBox 7"/>
           <p:cNvSpPr txBox="1"/>
           <p:nvPr/>
         </p:nvSpPr>

</xml_diff>

<commit_message>
Cierro con las preguntas que surgieron en vez de próximos pasos
</commit_message>
<xml_diff>
--- a/TP_instancia2_alquileres_CABA.pptx
+++ b/TP_instancia2_alquileres_CABA.pptx
@@ -10443,7 +10443,7 @@
                 </a:solidFill>
                 <a:latin typeface="Calibri"/>
               </a:rPr>
-              <a:t>Próximos pasos</a:t>
+              <a:t>Preguntas que surgieron…</a:t>
             </a:r>
           </a:p>
         </p:txBody>
@@ -10456,8 +10456,88 @@
         </p:nvSpPr>
         <p:spPr>
           <a:xfrm>
-            <a:off x="7132320" y="2834640"/>
-            <a:ext cx="4206240" cy="3108960"/>
+            <a:off x="7132320" y="2816352"/>
+            <a:ext cx="4206240" cy="2286000"/>
+          </a:xfrm>
+          <a:prstGeom prst="rect">
+            <a:avLst/>
+          </a:prstGeom>
+          <a:noFill/>
+        </p:spPr>
+        <p:txBody>
+          <a:bodyPr wrap="square" lIns="0" rIns="0" tIns="0" bIns="0" anchor="t">
+            <a:spAutoFit/>
+          </a:bodyPr>
+          <a:lstStyle/>
+          <a:p>
+            <a:pPr algn="l">
+              <a:lnSpc>
+                <a:spcPct val="116000"/>
+              </a:lnSpc>
+              <a:spcAft>
+                <a:spcPts val="1100"/>
+              </a:spcAft>
+            </a:pPr>
+            <a:r>
+              <a:rPr sz="1500" b="0">
+                <a:solidFill>
+                  <a:srgbClr val="15505E"/>
+                </a:solidFill>
+                <a:latin typeface="Calibri"/>
+              </a:rPr>
+              <a:t>¿Cuánto del pico de 2023 es la ley y cuánto la inflación?</a:t>
+            </a:r>
+          </a:p>
+          <a:p>
+            <a:pPr>
+              <a:lnSpc>
+                <a:spcPct val="116000"/>
+              </a:lnSpc>
+              <a:spcAft>
+                <a:spcPts val="1100"/>
+              </a:spcAft>
+            </a:pPr>
+            <a:r>
+              <a:rPr sz="1500" b="0">
+                <a:solidFill>
+                  <a:srgbClr val="15505E"/>
+                </a:solidFill>
+                <a:latin typeface="Calibri"/>
+              </a:rPr>
+              <a:t>¿Las comunas se agrupan solas por nivel, beta y faltantes, o ese agrupamiento no tiene nada que ver con las zonas?</a:t>
+            </a:r>
+          </a:p>
+          <a:p>
+            <a:pPr>
+              <a:lnSpc>
+                <a:spcPct val="116000"/>
+              </a:lnSpc>
+              <a:spcAft>
+                <a:spcPts val="1100"/>
+              </a:spcAft>
+            </a:pPr>
+            <a:r>
+              <a:rPr sz="1500" b="0">
+                <a:solidFill>
+                  <a:srgbClr val="15505E"/>
+                </a:solidFill>
+                <a:latin typeface="Calibri"/>
+              </a:rPr>
+              <a:t>¿La beta de una comuna tiene que ver con el ingreso de quienes viven ahí?</a:t>
+            </a:r>
+          </a:p>
+        </p:txBody>
+      </p:sp>
+      <p:sp>
+        <p:nvSpPr>
+          <p:cNvPr id="9" name="TextBox 8"/>
+          <p:cNvSpPr txBox="1"/>
+          <p:nvPr/>
+        </p:nvSpPr>
+        <p:spPr>
+          <a:xfrm>
+            <a:off x="7132320" y="5120640"/>
+            <a:ext cx="4206240" cy="1280160"/>
           </a:xfrm>
           <a:prstGeom prst="rect">
             <a:avLst/>
@@ -10479,51 +10559,22 @@
               </a:spcAft>
             </a:pPr>
             <a:r>
-              <a:rPr sz="1550" b="0">
+              <a:rPr sz="1400" b="1">
                 <a:solidFill>
                   <a:srgbClr val="15505E"/>
                 </a:solidFill>
                 <a:latin typeface="Calibri"/>
               </a:rPr>
-              <a:t>Clustering de comunas por nivel, beta y faltantes, para ver si los grupos coinciden con las zonas.</a:t>
+              <a:t>Para la próxima. </a:t>
             </a:r>
-          </a:p>
-          <a:p>
-            <a:pPr>
-              <a:lnSpc>
-                <a:spcPct val="116000"/>
-              </a:lnSpc>
-              <a:spcAft>
-                <a:spcPts val="1300"/>
-              </a:spcAft>
-            </a:pPr>
             <a:r>
-              <a:rPr sz="1550" b="0">
+              <a:rPr sz="1400" b="0">
                 <a:solidFill>
                   <a:srgbClr val="15505E"/>
                 </a:solidFill>
                 <a:latin typeface="Calibri"/>
               </a:rPr>
-              <a:t>Separar la ley de la inflación comparando trimestres de inflación alta y baja dentro de cada período.</a:t>
-            </a:r>
-          </a:p>
-          <a:p>
-            <a:pPr>
-              <a:lnSpc>
-                <a:spcPct val="116000"/>
-              </a:lnSpc>
-              <a:spcAft>
-                <a:spcPts val="1300"/>
-              </a:spcAft>
-            </a:pPr>
-            <a:r>
-              <a:rPr sz="1550" b="0">
-                <a:solidFill>
-                  <a:srgbClr val="15505E"/>
-                </a:solidFill>
-                <a:latin typeface="Calibri"/>
-              </a:rPr>
-              <a:t>Sumar ingresos por comuna (EAH) para relacionar la beta con la capacidad de pago.</a:t>
+              <a:t>Probaríamos un clustering y sumaríamos los ingresos por comuna de la EAH. Y nos llevamos dos candidatos a visualización para la instancia 3: el gráfico de faltantes y el de beta contra nivel.</a:t>
             </a:r>
           </a:p>
         </p:txBody>

</xml_diff>